<commit_message>
Improve policy tradeoff research workflow
</commit_message>
<xml_diff>
--- a/output/final_decision.pptx
+++ b/output/final_decision.pptx
@@ -3114,7 +3114,7 @@
               <a:defRPr sz="2600" b="1"/>
             </a:pPr>
             <a:r>
-              <a:t>India E20 ethanol‑blending target</a:t>
+              <a:t>India E20 ethanol‑blending target – decision between Rapid Expansion and Gradual Adoption</a:t>
             </a:r>
           </a:p>
         </p:txBody>
@@ -3145,7 +3145,7 @@
               <a:defRPr sz="1800" b="1"/>
             </a:pPr>
             <a:r>
-              <a:t>Recommended: Gradual E20 adoption</a:t>
+              <a:t>Recommended: Gradual Adoption</a:t>
             </a:r>
           </a:p>
         </p:txBody>
@@ -3176,7 +3176,7 @@
               <a:defRPr sz="1300" b="0"/>
             </a:pPr>
             <a:r>
-              <a:t>Deterministic Scores — Rapid E20 expansion: 4.7 | Gradual E20 adoption: 5.6</a:t>
+              <a:t>Deterministic Scores — Rapid Expansion: 4.7 | Gradual Adoption: 6.3</a:t>
             </a:r>
           </a:p>
         </p:txBody>
@@ -3215,7 +3215,7 @@
               <a:defRPr sz="1200" b="0"/>
             </a:pPr>
             <a:r>
-              <a:t>- Rapid expansion – strong energy‑security benefit but heightened food‑price pressure, groundwater drawdown, and older‑vehicle wear.</a:t>
+              <a:t>- Rapid Expansion offers immediate foreign‑exchange savings but raises water stress and consumer costs</a:t>
             </a:r>
           </a:p>
           <a:p>
@@ -3223,7 +3223,7 @@
               <a:defRPr sz="1200" b="0"/>
             </a:pPr>
             <a:r>
-              <a:t>- Gradual adoption – preserves food/water resources and protects legacy vehicles but yields smaller import‑cost reduction.</a:t>
+              <a:t>- Gradual Adoption preserves water resources and limits mileage penalties but delays energy‑security gains</a:t>
             </a:r>
           </a:p>
         </p:txBody>
@@ -3262,7 +3262,7 @@
               <a:defRPr sz="1200" b="0"/>
             </a:pPr>
             <a:r>
-              <a:t>- Energy lens favors Rapid expansion; Food/Water and Vehicle/Consumer lenses favor Gradual adoption.</a:t>
+              <a:t>- Energy lens favors Rapid Expansion while Food/Water and Vehicle/Consumer lenses favor Gradual Adoption</a:t>
             </a:r>
           </a:p>
           <a:p>
@@ -3283,7 +3283,7 @@
               <a:defRPr sz="1200" b="0"/>
             </a:pPr>
             <a:r>
-              <a:t>- Assumes current feedstock trends persist; does not factor potential advances in low‑water‑use crops or engine retrofits.</a:t>
+              <a:t>- Assumes current technology trends continue; abrupt policy shifts could alter scores</a:t>
             </a:r>
           </a:p>
         </p:txBody>
@@ -3314,7 +3314,7 @@
               <a:defRPr sz="1200" b="0"/>
             </a:pPr>
             <a:r>
-              <a:t>Applies under: Ethanol supply remains constrained; Groundwater depletion continues; A sizable share of the vehicle fleet remains pre‑2015</a:t>
+              <a:t>Applies under: Recommendation holds if water‑stress regions remain vulnerable and older vehicle stock stays &gt;30% of fleet; If ethanol‑yield technologies double or fuel‑price premiums shrink, rapid rollout may become preferable</a:t>
             </a:r>
           </a:p>
         </p:txBody>
@@ -3345,7 +3345,7 @@
               <a:defRPr sz="900" b="0"/>
             </a:pPr>
             <a:r>
-              <a:t>Sources: Mongabay India (2026); DowntoEarth (2025); Economic Times (2026)</a:t>
+              <a:t>Sources: Energy findings: PIB Factsheet; BBC; Eurasia Review; ForumIAS; IEA AMF India report; Food &amp; Water findings: Mongabay 2026; Rediff 2026; ResearchGate 2026; HP CL Facebook post 2023; Chetan Bharat 2026; Vehicle &amp; Consumer findings: Reuters 2025; ARAI press release 2026; SIAM statement; Team‑BHP discussion</a:t>
             </a:r>
           </a:p>
         </p:txBody>

</xml_diff>